<commit_message>
feat(参赛): 用 humanizer-zh-pro 重写答辩 PPT 文案（11 页）
用户要求调用「让 AI 输出更像人类表达」的技能。技能市场装了 humanizer-zh-pro（中文降AI味），
它明确针对汇报材料，按知网/万方/维普检测器校准。

按其规则重写全部 11 页文案：
- 删二元对比与三件套排比（不是…而是…、三个「可」连用）
- 删金句式标题（「0.05 的容差把感觉变差变成命令失败」→「容差 0.05，掉出这个范围就算失败」）
- 删空洞引领词与万能动词；给每句补上主语
- 破折号减到每页 0–1 处；箭头改成句号断句；状态词「达标/部分/未做」→「达标/一半/没做」
- 保留结论式标题这一**结构要求**，只去掉对偶与排比；术语与数字全部保持准确

改写已落到 kami_slides.py 并重新生成：11 页 / 168 KB / 页名 11/11 落盘 / validate 无错。
</commit_message>
<xml_diff>
--- a/docs/作品集/参赛/知迹答辩/知迹答辩.pptx
+++ b/docs/作品集/参赛/知迹答辩/知迹答辩.pptx
@@ -3090,7 +3090,7 @@
 
 <file path=ppt/slides/slide1.xml><?xml version="1.0" encoding="utf-8"?>
 <p:sld xmlns:a="http://schemas.openxmlformats.org/drawingml/2006/main" xmlns:p="http://schemas.openxmlformats.org/presentationml/2006/main" xmlns:r="http://schemas.openxmlformats.org/officeDocument/2006/relationships">
-  <p:cSld name="01 封面｜知迹：把一次学习回合做成可恢复、可拦截、可度量的状态图">
+  <p:cSld name="01 封面｜一次学习回合拆成四个节点，每步存档，写库前先问一句">
     <p:spTree>
       <p:nvGrpSpPr>
         <p:cNvPr id="1" name=""/>
@@ -3329,7 +3329,7 @@
                 <a:ea typeface="Songti SC"/>
                 <a:cs typeface="Songti SC"/>
               </a:rPr>
-              <a:t>核心命题：把一次学习回合做成一张可恢复、可拦截、可度量的状态图 —— 而不是不可控的聊天框</a:t>
+              <a:t>一次学习回合被拆成四个节点，每一步都存档；写进你的资料库之前，它会先问一句。</a:t>
             </a:r>
           </a:p>
         </p:txBody>
@@ -3677,7 +3677,7 @@
 
 <file path=ppt/slides/slide10.xml><?xml version="1.0" encoding="utf-8"?>
 <p:sld xmlns:a="http://schemas.openxmlformats.org/drawingml/2006/main" xmlns:p="http://schemas.openxmlformats.org/presentationml/2006/main" xmlns:r="http://schemas.openxmlformats.org/officeDocument/2006/relationships">
-  <p:cSld name="10 边界｜六项能力：两项达标、三项部分达成、一项未做">
+  <p:cSld name="10 边界｜六项能力：两项达标，三项一半，一项没做">
     <p:spTree>
       <p:nvGrpSpPr>
         <p:cNvPr id="1" name=""/>
@@ -3798,7 +3798,7 @@
                 <a:ea typeface="Songti SC"/>
                 <a:cs typeface="Songti SC"/>
               </a:rPr>
-              <a:t>六项能力：两项达标、三项部分达成、一项未做</a:t>
+              <a:t>六项能力：两项达标，三项只做了一半，一项没做</a:t>
             </a:r>
           </a:p>
         </p:txBody>
@@ -3909,7 +3909,7 @@
                 <a:ea typeface="Songti SC"/>
                 <a:cs typeface="Songti SC"/>
               </a:rPr>
-              <a:t>依据 / 尚缺什么</a:t>
+              <a:t>依据 / 还缺什么</a:t>
             </a:r>
           </a:p>
         </p:txBody>
@@ -4145,7 +4145,7 @@
                 <a:ea typeface="Songti SC"/>
                 <a:cs typeface="Songti SC"/>
               </a:rPr>
-              <a:t>检索准确性 / 可追溯</a:t>
+              <a:t>检索准确 / 可追溯</a:t>
             </a:r>
           </a:p>
         </p:txBody>
@@ -4337,7 +4337,7 @@
                 <a:ea typeface="Songti SC"/>
                 <a:cs typeface="Songti SC"/>
               </a:rPr>
-              <a:t>部分</a:t>
+              <a:t>一半</a:t>
             </a:r>
           </a:p>
         </p:txBody>
@@ -4492,7 +4492,7 @@
                 <a:ea typeface="Songti SC"/>
                 <a:cs typeface="Songti SC"/>
               </a:rPr>
-              <a:t>部分</a:t>
+              <a:t>一半</a:t>
             </a:r>
           </a:p>
         </p:txBody>
@@ -4647,7 +4647,7 @@
                 <a:ea typeface="Songti SC"/>
                 <a:cs typeface="Songti SC"/>
               </a:rPr>
-              <a:t>部分</a:t>
+              <a:t>一半</a:t>
             </a:r>
           </a:p>
         </p:txBody>
@@ -4802,7 +4802,7 @@
                 <a:ea typeface="Songti SC"/>
                 <a:cs typeface="Songti SC"/>
               </a:rPr>
-              <a:t>未做</a:t>
+              <a:t>没做</a:t>
             </a:r>
           </a:p>
         </p:txBody>
@@ -4839,7 +4839,7 @@
                 <a:ea typeface="Songti SC"/>
                 <a:cs typeface="Songti SC"/>
               </a:rPr>
-              <a:t>现有考卷只测「找到没 / 分类对不对」，不测「本次会话是否达成目标」</a:t>
+              <a:t>现有考卷只测「找到没」「分类对不对」，不测「这次会话有没有用」</a:t>
             </a:r>
           </a:p>
         </p:txBody>
@@ -4876,7 +4876,7 @@
                 <a:ea typeface="Songti SC"/>
                 <a:cs typeface="Songti SC"/>
               </a:rPr>
-              <a:t>下一步优先级：任务级成功率评测 → 记忆生命周期 → 更难的检索考卷；均可在现有门禁内验证</a:t>
+              <a:t>接下来按这个顺序补：任务级成功率评测 → 记忆的过期与删除 → 更难的检索考卷。三项都能在现有门禁里验证。</a:t>
             </a:r>
           </a:p>
         </p:txBody>
@@ -4928,7 +4928,7 @@
 
 <file path=ppt/slides/slide11.xml><?xml version="1.0" encoding="utf-8"?>
 <p:sld xmlns:a="http://schemas.openxmlformats.org/drawingml/2006/main" xmlns:p="http://schemas.openxmlformats.org/presentationml/2006/main" xmlns:r="http://schemas.openxmlformats.org/officeDocument/2006/relationships">
-  <p:cSld name="11 收束｜让 AI 帮上忙靠的是每一步都留痕、可拦、可复算">
+  <p:cSld name="11 收束｜真正做完的是三件事">
     <p:spTree>
       <p:nvGrpSpPr>
         <p:cNvPr id="1" name=""/>
@@ -5049,7 +5049,7 @@
                 <a:ea typeface="Songti SC"/>
                 <a:cs typeface="Songti SC"/>
               </a:rPr>
-              <a:t>让 AI 帮上忙，靠的不是它多聪明，而是每一步都留痕、能被拦住、也能被复算。</a:t>
+              <a:t>真正做完的是三件事：每一步留痕，越权拦得住，变差算得出来。</a:t>
             </a:r>
           </a:p>
         </p:txBody>
@@ -5130,7 +5130,7 @@
                 <a:ea typeface="Songti SC"/>
                 <a:cs typeface="Songti SC"/>
               </a:rPr>
-              <a:t>我们把它做成一个可交付的系统：能力有边界，缺口自己说出来，改动由指标说了算。</a:t>
+              <a:t>其余的还差着，已经写在上一页。我们把它做成一个能交付的系统：能做什么说清楚，缺什么也写在纸上。</a:t>
             </a:r>
           </a:p>
         </p:txBody>
@@ -5204,7 +5204,7 @@
                 <a:ea typeface="Songti SC"/>
                 <a:cs typeface="Songti SC"/>
               </a:rPr>
-              <a:t>从「找到没」升级到「一次会话是否达成目标」</a:t>
+              <a:t>从「找到没」升级到「这次会话有没有用」</a:t>
             </a:r>
           </a:p>
         </p:txBody>
@@ -5485,7 +5485,7 @@
 
 <file path=ppt/slides/slide2.xml><?xml version="1.0" encoding="utf-8"?>
 <p:sld xmlns:a="http://schemas.openxmlformats.org/drawingml/2006/main" xmlns:p="http://schemas.openxmlformats.org/presentationml/2006/main" xmlns:r="http://schemas.openxmlformats.org/officeDocument/2006/relationships">
-  <p:cSld name="02 目录｜五段路线，结论先行">
+  <p:cSld name="02 目录｜五段路线，第 3 页先给结论">
     <p:spTree>
       <p:nvGrpSpPr>
         <p:cNvPr id="1" name=""/>
@@ -5976,7 +5976,7 @@
                 <a:ea typeface="Songti SC"/>
                 <a:cs typeface="Songti SC"/>
               </a:rPr>
-              <a:t>结论先行：下一页给出三条结论，后面每页只负责证明其中一条</a:t>
+              <a:t>第 3 页先把结论摆出来，后面每一页只负责证明其中一条</a:t>
             </a:r>
           </a:p>
         </p:txBody>
@@ -5991,7 +5991,7 @@
 
 <file path=ppt/slides/slide3.xml><?xml version="1.0" encoding="utf-8"?>
 <p:sld xmlns:a="http://schemas.openxmlformats.org/drawingml/2006/main" xmlns:p="http://schemas.openxmlformats.org/presentationml/2006/main" xmlns:r="http://schemas.openxmlformats.org/officeDocument/2006/relationships">
-  <p:cSld name="03 背景｜三个时刻的共性缺口：产出无法复用，复习成本被迫翻倍">
+  <p:cSld name="03 背景｜三个时刻，同一个毛病：用过的东西留不下来">
     <p:spTree>
       <p:nvGrpSpPr>
         <p:cNvPr id="1" name=""/>
@@ -6112,7 +6112,7 @@
                 <a:ea typeface="Songti SC"/>
                 <a:cs typeface="Songti SC"/>
               </a:rPr>
-              <a:t>三个时刻的共性缺口：产出无法复用，复习成本被迫翻倍</a:t>
+              <a:t>三个时刻，同一个毛病：用过的东西留不下来</a:t>
             </a:r>
           </a:p>
         </p:txBody>
@@ -6230,7 +6230,7 @@
                 <a:ea typeface="Songti SC"/>
                 <a:cs typeface="Songti SC"/>
               </a:rPr>
-              <a:t>上课中 · 讲义散在三处</a:t>
+              <a:t>上课时，讲义散在三处</a:t>
             </a:r>
           </a:p>
         </p:txBody>
@@ -6267,7 +6267,7 @@
                 <a:ea typeface="Songti SC"/>
                 <a:cs typeface="Songti SC"/>
               </a:rPr>
-              <a:t>课程平台、聊天记录、手机相册各存一半，找一页要翻三个地方 → 不可检索</a:t>
+              <a:t>课程平台、聊天记录、手机相册各存一半，找一页要翻三个地方。检索不了。</a:t>
             </a:r>
           </a:p>
         </p:txBody>
@@ -6304,7 +6304,7 @@
                 <a:ea typeface="Songti SC"/>
                 <a:cs typeface="Songti SC"/>
               </a:rPr>
-              <a:t>写作业 · 问完就走</a:t>
+              <a:t>写作业，问一句就走</a:t>
             </a:r>
           </a:p>
         </p:txBody>
@@ -6341,7 +6341,7 @@
                 <a:ea typeface="Songti SC"/>
                 <a:cs typeface="Songti SC"/>
               </a:rPr>
-              <a:t>答案留在对话里，同类问题下次从零再问 → 不可复用</a:t>
+              <a:t>答案留在对话框里，同类问题下次还得从零问一遍。复用不了。</a:t>
             </a:r>
           </a:p>
         </p:txBody>
@@ -6378,7 +6378,7 @@
                 <a:ea typeface="Songti SC"/>
                 <a:cs typeface="Songti SC"/>
               </a:rPr>
-              <a:t>期末时 · 资料在、题没有</a:t>
+              <a:t>期末，资料在，题没有</a:t>
             </a:r>
           </a:p>
         </p:txBody>
@@ -6415,7 +6415,7 @@
                 <a:ea typeface="Songti SC"/>
                 <a:cs typeface="Songti SC"/>
               </a:rPr>
-              <a:t>只能重读讲义重翻记录，练习量不足 → 不可练</a:t>
+              <a:t>只能重读讲义、重翻记录，练的量不够。可练的题是空的。</a:t>
             </a:r>
           </a:p>
         </p:txBody>
@@ -6452,7 +6452,7 @@
                 <a:ea typeface="Songti SC"/>
                 <a:cs typeface="Songti SC"/>
               </a:rPr>
-              <a:t>由此定义四个可验证目标</a:t>
+              <a:t>我们把这件事拆成四个能验收的目标</a:t>
             </a:r>
           </a:p>
         </p:txBody>
@@ -6489,7 +6489,7 @@
                 <a:ea typeface="Songti SC"/>
                 <a:cs typeface="Songti SC"/>
               </a:rPr>
-              <a:t>G1　中断后可无损续跑</a:t>
+              <a:t>G1　中断后接着跑</a:t>
             </a:r>
           </a:p>
         </p:txBody>
@@ -6526,7 +6526,7 @@
                 <a:ea typeface="Songti SC"/>
                 <a:cs typeface="Songti SC"/>
               </a:rPr>
-              <a:t>关页或断网后，能从未完成处继续</a:t>
+              <a:t>关页或断网再回来，能从上次的进度继续</a:t>
             </a:r>
           </a:p>
         </p:txBody>
@@ -6563,7 +6563,7 @@
                 <a:ea typeface="Songti SC"/>
                 <a:cs typeface="Songti SC"/>
               </a:rPr>
-              <a:t>G2　答案可追溯到具体页</a:t>
+              <a:t>G2　答案能翻到页</a:t>
             </a:r>
           </a:p>
         </p:txBody>
@@ -6600,7 +6600,7 @@
                 <a:ea typeface="Songti SC"/>
                 <a:cs typeface="Songti SC"/>
               </a:rPr>
-              <a:t>引用带「第 N 页」，原件可打开核对</a:t>
+              <a:t>引用带「第 N 页」，原件点开就能核对</a:t>
             </a:r>
           </a:p>
         </p:txBody>
@@ -6637,7 +6637,7 @@
                 <a:ea typeface="Songti SC"/>
                 <a:cs typeface="Songti SC"/>
               </a:rPr>
-              <a:t>G3　数据不被越权修改</a:t>
+              <a:t>G3　数据不被乱改</a:t>
             </a:r>
           </a:p>
         </p:txBody>
@@ -6674,7 +6674,7 @@
                 <a:ea typeface="Songti SC"/>
                 <a:cs typeface="Songti SC"/>
               </a:rPr>
-              <a:t>写操作在执行层被拦，确认后才落库</a:t>
+              <a:t>写操作在执行层被拦，确认之后才落库</a:t>
             </a:r>
           </a:p>
         </p:txBody>
@@ -6711,7 +6711,7 @@
                 <a:ea typeface="Songti SC"/>
                 <a:cs typeface="Songti SC"/>
               </a:rPr>
-              <a:t>G4　改动好坏可被量化</a:t>
+              <a:t>G4　好坏算得出来</a:t>
             </a:r>
           </a:p>
         </p:txBody>
@@ -6748,7 +6748,7 @@
                 <a:ea typeface="Songti SC"/>
                 <a:cs typeface="Songti SC"/>
               </a:rPr>
-              <a:t>固定考卷 + 基线，掉分自动拦截</a:t>
+              <a:t>固定考卷加基线，掉分自动拦下</a:t>
             </a:r>
           </a:p>
         </p:txBody>
@@ -6785,7 +6785,7 @@
                 <a:ea typeface="Songti SC"/>
                 <a:cs typeface="Songti SC"/>
               </a:rPr>
-              <a:t>问题不在「有没有工具」，而在「用完即弃」：讲义、结论、错因都没留下可复用的形态</a:t>
+              <a:t>缺的不是工具，是把用过的东西留下来：讲义、结论、错因，停下来就还是「用过」。</a:t>
             </a:r>
           </a:p>
         </p:txBody>
@@ -6837,7 +6837,7 @@
 
 <file path=ppt/slides/slide4.xml><?xml version="1.0" encoding="utf-8"?>
 <p:sld xmlns:a="http://schemas.openxmlformats.org/drawingml/2006/main" xmlns:p="http://schemas.openxmlformats.org/presentationml/2006/main" xmlns:r="http://schemas.openxmlformats.org/officeDocument/2006/relationships">
-  <p:cSld name="04 技术选型｜零运维、可离线、可评测，不是追新">
+  <p:cSld name="04 技术选型｜只守三条：零运维、能离线、可评测">
     <p:spTree>
       <p:nvGrpSpPr>
         <p:cNvPr id="1" name=""/>
@@ -6958,7 +6958,7 @@
                 <a:ea typeface="Songti SC"/>
                 <a:cs typeface="Songti SC"/>
               </a:rPr>
-              <a:t>选型原则是零运维、可离线、可评测，不是追新</a:t>
+              <a:t>选型只守三条：零运维、能离线、可评测</a:t>
             </a:r>
           </a:p>
         </p:txBody>
@@ -7106,7 +7106,7 @@
                 <a:ea typeface="Songti SC"/>
                 <a:cs typeface="Songti SC"/>
               </a:rPr>
-              <a:t>为什么不选更常见的替代</a:t>
+              <a:t>没选什么，为什么</a:t>
             </a:r>
           </a:p>
         </p:txBody>
@@ -7298,7 +7298,7 @@
                 <a:ea typeface="Songti SC"/>
                 <a:cs typeface="Songti SC"/>
               </a:rPr>
-              <a:t>自研状态机要重复实现断点与中断</a:t>
+              <a:t>自研状态机，断点和中断还得自己写一遍</a:t>
             </a:r>
           </a:p>
         </p:txBody>
@@ -7490,7 +7490,7 @@
                 <a:ea typeface="Songti SC"/>
                 <a:cs typeface="Songti SC"/>
               </a:rPr>
-              <a:t>同步框架难以边算边推，过程不可见</a:t>
+              <a:t>同步框架边算边推做不到，过程也就看不见</a:t>
             </a:r>
           </a:p>
         </p:txBody>
@@ -7645,7 +7645,7 @@
                 <a:ea typeface="Songti SC"/>
                 <a:cs typeface="Songti SC"/>
               </a:rPr>
-              <a:t>单文件承载全部业务数据与检索索引</a:t>
+              <a:t>单文件装下全部业务数据与检索索引</a:t>
             </a:r>
           </a:p>
         </p:txBody>
@@ -7682,7 +7682,7 @@
                 <a:ea typeface="Songti SC"/>
                 <a:cs typeface="Songti SC"/>
               </a:rPr>
-              <a:t>换 MySQL 会牺牲中文检索与离线演示</a:t>
+              <a:t>换 MySQL 会牺牲中文检索和离线演示</a:t>
             </a:r>
           </a:p>
         </p:txBody>
@@ -7874,7 +7874,7 @@
                 <a:ea typeface="Songti SC"/>
                 <a:cs typeface="Songti SC"/>
               </a:rPr>
-              <a:t>纯向量漏专有名词与两字词</a:t>
+              <a:t>纯向量会漏掉专有名词和两字词</a:t>
             </a:r>
           </a:p>
         </p:txBody>
@@ -8066,7 +8066,7 @@
                 <a:ea typeface="Songti SC"/>
                 <a:cs typeface="Songti SC"/>
               </a:rPr>
-              <a:t>纯 SPA 处理流式与多页状态更绕</a:t>
+              <a:t>纯 SPA 处理流式和多页状态更绕</a:t>
             </a:r>
           </a:p>
         </p:txBody>
@@ -8295,7 +8295,7 @@
                 <a:ea typeface="Songti SC"/>
                 <a:cs typeface="Songti SC"/>
               </a:rPr>
-              <a:t>结果：整条链路可离线跑通，测试与评测零 API 消耗 —— 这是能反复验证的前提</a:t>
+              <a:t>这样整条链路都能离线跑通，测试和评测一次 API 都不花——这是能反复验证的前提。</a:t>
             </a:r>
           </a:p>
         </p:txBody>
@@ -8347,7 +8347,7 @@
 
 <file path=ppt/slides/slide5.xml><?xml version="1.0" encoding="utf-8"?>
 <p:sld xmlns:a="http://schemas.openxmlformats.org/drawingml/2006/main" xmlns:p="http://schemas.openxmlformats.org/presentationml/2006/main" xmlns:r="http://schemas.openxmlformats.org/officeDocument/2006/relationships">
-  <p:cSld name="05 架构｜依赖单向朝内、回合画成图">
+  <p:cSld name="05 架构｜依赖只朝内，回合画成图">
     <p:spTree>
       <p:nvGrpSpPr>
         <p:cNvPr id="1" name=""/>
@@ -8468,7 +8468,7 @@
                 <a:ea typeface="Songti SC"/>
                 <a:cs typeface="Songti SC"/>
               </a:rPr>
-              <a:t>依赖单向朝内、回合画成图</a:t>
+              <a:t>依赖只朝内，回合画成图</a:t>
             </a:r>
           </a:p>
         </p:txBody>
@@ -9215,7 +9215,7 @@
                 <a:ea typeface="Songti SC"/>
                 <a:cs typeface="Songti SC"/>
               </a:rPr>
-              <a:t>每个节点执行后都落一次检查点 —— 这既是「关掉页面还能接着跑」，也是「写库前停下问你」的共同前提</a:t>
+              <a:t>每跑完一个节点就存一次档。关掉页面还能接着跑、写库前先停下来问你，靠的都是这一点。</a:t>
             </a:r>
           </a:p>
         </p:txBody>
@@ -9267,7 +9267,7 @@
 
 <file path=ppt/slides/slide6.xml><?xml version="1.0" encoding="utf-8"?>
 <p:sld xmlns:a="http://schemas.openxmlformats.org/drawingml/2006/main" xmlns:p="http://schemas.openxmlformats.org/presentationml/2006/main" xmlns:r="http://schemas.openxmlformats.org/officeDocument/2006/relationships">
-  <p:cSld name="06 实现一｜四路召回补上中文短词与同义异名两类漏召回">
+  <p:cSld name="06 实现一｜四条一起找，把中文短词和同义异名都补上">
     <p:spTree>
       <p:nvGrpSpPr>
         <p:cNvPr id="1" name=""/>
@@ -9388,7 +9388,7 @@
                 <a:ea typeface="Songti SC"/>
                 <a:cs typeface="Songti SC"/>
               </a:rPr>
-              <a:t>四路召回同时补上「中文短词」与「同义异名」两类漏召回</a:t>
+              <a:t>四条一起找，把中文短词和同义异名都补上</a:t>
             </a:r>
           </a:p>
         </p:txBody>
@@ -10016,7 +10016,7 @@
                 <a:ea typeface="Songti SC"/>
                 <a:cs typeface="Songti SC"/>
               </a:rPr>
-              <a:t>局限：无真实模型时不可靠</a:t>
+              <a:t>局限：没有真实模型时不可靠</a:t>
             </a:r>
           </a:p>
         </p:txBody>
@@ -10053,7 +10053,7 @@
                 <a:ea typeface="Songti SC"/>
                 <a:cs typeface="Songti SC"/>
               </a:rPr>
-              <a:t>四条不是堆料：每条都对应一个实测过的漏召回场景。消融：关掉精排后 MRR 由 0.9714 降至 0.9571，命中数不变 —— 它改善的是排序，不是召回</a:t>
+              <a:t>这四条不是凑数，每条都对应一类真实漏掉的查询。关掉精排，MRR 从 0.9714 掉到 0.9571，命中数没变——它改善的是排序，不是召回。</a:t>
             </a:r>
           </a:p>
         </p:txBody>
@@ -10105,7 +10105,7 @@
 
 <file path=ppt/slides/slide7.xml><?xml version="1.0" encoding="utf-8"?>
 <p:sld xmlns:a="http://schemas.openxmlformats.org/drawingml/2006/main" xmlns:p="http://schemas.openxmlformats.org/presentationml/2006/main" xmlns:r="http://schemas.openxmlformats.org/officeDocument/2006/relationships">
-  <p:cSld name="07 实现二｜检查点负责接着跑，权限两层负责改不了">
+  <p:cSld name="07 实现二｜接着跑靠检查点，改不了靠两层权限">
     <p:spTree>
       <p:nvGrpSpPr>
         <p:cNvPr id="1" name=""/>
@@ -10226,7 +10226,7 @@
                 <a:ea typeface="Songti SC"/>
                 <a:cs typeface="Songti SC"/>
               </a:rPr>
-              <a:t>检查点负责「接着跑」，权限两层负责「改不了」</a:t>
+              <a:t>接着跑靠检查点，改不了靠两层权限</a:t>
             </a:r>
           </a:p>
         </p:txBody>
@@ -10640,7 +10640,7 @@
                 <a:ea typeface="Songti SC"/>
                 <a:cs typeface="Songti SC"/>
               </a:rPr>
-              <a:t>看得见全部工具 · 执行层放行，写操作仍需确认</a:t>
+              <a:t>看得见全部工具，执行层放行；写操作仍要确认</a:t>
             </a:r>
           </a:p>
         </p:txBody>
@@ -10714,7 +10714,7 @@
                 <a:ea typeface="Songti SC"/>
                 <a:cs typeface="Songti SC"/>
               </a:rPr>
-              <a:t>看得见只读工具 · 执行层直接拒绝写操作</a:t>
+              <a:t>看得见只读工具，执行层直接拒绝写操作</a:t>
             </a:r>
           </a:p>
         </p:txBody>
@@ -10788,7 +10788,7 @@
                 <a:ea typeface="Songti SC"/>
                 <a:cs typeface="Songti SC"/>
               </a:rPr>
-              <a:t>看不见任何工具 · 执行层一律拦截</a:t>
+              <a:t>看不见任何工具，执行层一律拦截</a:t>
             </a:r>
           </a:p>
         </p:txBody>
@@ -10825,7 +10825,7 @@
                 <a:ea typeface="Songti SC"/>
                 <a:cs typeface="Songti SC"/>
               </a:rPr>
-              <a:t>写操作流程：模型发起落库 → 图在中断点暂停 → 用户点确认 → 从检查点恢复并落库。两层权限缺一不可：只遮列表模型仍会说出被禁工具名而失败，只拦执行模型会反复重试</a:t>
+              <a:t>写库的流程是：模型要写 → 图停下来 → 人点确认 → 从检查点恢复再落库。两层权限都得有：只藏工具，模型仍会说出被禁的名字然后失败；只在执行时拦，模型会一遍遍重试。</a:t>
             </a:r>
           </a:p>
         </p:txBody>
@@ -10877,7 +10877,7 @@
 
 <file path=ppt/slides/slide8.xml><?xml version="1.0" encoding="utf-8"?>
 <p:sld xmlns:a="http://schemas.openxmlformats.org/drawingml/2006/main" xmlns:p="http://schemas.openxmlformats.org/presentationml/2006/main" xmlns:r="http://schemas.openxmlformats.org/officeDocument/2006/relationships">
-  <p:cSld name="08 实现三｜0.05 的容差把感觉变差变成命令失败">
+  <p:cSld name="08 实现三｜容差 0.05，掉出这个范围就算失败">
     <p:spTree>
       <p:nvGrpSpPr>
         <p:cNvPr id="1" name=""/>
@@ -10998,7 +10998,7 @@
                 <a:ea typeface="Songti SC"/>
                 <a:cs typeface="Songti SC"/>
               </a:rPr>
-              <a:t>0.05 的容差把「感觉变差」变成「命令失败」</a:t>
+              <a:t>容差 0.05，掉出这个范围就算失败</a:t>
             </a:r>
           </a:p>
         </p:txBody>
@@ -11375,8 +11375,7 @@
                 <a:ea typeface="Songti SC"/>
                 <a:cs typeface="Songti SC"/>
               </a:rPr>
-              <a:t>为什么不用大模型判分：同一模型既写又评会共享盲区 —— 它看不见的错误，复核时也看不见，甚至会把好答案改坏。
-所以判据全部用「确定性比对」：命中的是哪一篇、分到的是哪一类，机器都能校验；模型的判断只用于人工抽检。</a:t>
+              <a:t>判分没有交给大模型。同一模型既写又评，会共享同一批盲区：它第一次没看出来的错，复核时同样看不出来，还可能把本来对的答案改坏。所以判据都用能机器校验的方式——命中的是哪一篇、分到了哪一类。模型的意见只用在人工抽检上。</a:t>
             </a:r>
           </a:p>
         </p:txBody>
@@ -11465,7 +11464,7 @@
 
 <file path=ppt/slides/slide9.xml><?xml version="1.0" encoding="utf-8"?>
 <p:sld xmlns:a="http://schemas.openxmlformats.org/drawingml/2006/main" xmlns:p="http://schemas.openxmlformats.org/presentationml/2006/main" xmlns:r="http://schemas.openxmlformats.org/officeDocument/2006/relationships">
-  <p:cSld name="09 实际使用｜四步走完一个学习周期：入库、溯源、记错因、到期复习">
+  <p:cSld name="09 实际使用｜四步走完一个学习周期">
     <p:spTree>
       <p:nvGrpSpPr>
         <p:cNvPr id="1" name=""/>
@@ -11586,7 +11585,7 @@
                 <a:ea typeface="Songti SC"/>
                 <a:cs typeface="Songti SC"/>
               </a:rPr>
-              <a:t>四步走完一个学习周期：入库、溯源、记错因、到期复习</a:t>
+              <a:t>四步走完一个学习周期</a:t>
             </a:r>
           </a:p>
         </p:txBody>
@@ -11647,7 +11646,7 @@
                 <a:ea typeface="Songti SC"/>
                 <a:cs typeface="Songti SC"/>
               </a:rPr>
-              <a:t>知识库页实拍：左侧学科目录树，中间资料列表，右侧可直接就着当前库提问</a:t>
+              <a:t>知识库页实拍：左边是学科目录树，中间是资料列表，右侧可以直接就着当前这个库提问</a:t>
             </a:r>
           </a:p>
         </p:txBody>
@@ -11758,7 +11757,7 @@
                 <a:ea typeface="Songti SC"/>
                 <a:cs typeface="Songti SC"/>
               </a:rPr>
-              <a:t>PDF / Word / PPT / Excel 秒传，板书照片经视觉转写后入库</a:t>
+              <a:t>PDF / Word / PPT / Excel 秒传；板书照片经视觉转写后入库</a:t>
             </a:r>
           </a:p>
         </p:txBody>
@@ -11869,7 +11868,7 @@
                 <a:ea typeface="Songti SC"/>
                 <a:cs typeface="Songti SC"/>
               </a:rPr>
-              <a:t>回答标注出自哪份资料、第几页，原件可内联打开核对</a:t>
+              <a:t>回答标着出自哪份资料第几页，原件点开就能核对</a:t>
             </a:r>
           </a:p>
         </p:txBody>
@@ -12091,7 +12090,7 @@
                 <a:ea typeface="Songti SC"/>
                 <a:cs typeface="Songti SC"/>
               </a:rPr>
-              <a:t>今日复习只列到期题与薄弱学科，日程负责什么时候做</a:t>
+              <a:t>今日复习只列到期题和薄弱学科，日程管什么时候做</a:t>
             </a:r>
           </a:p>
         </p:txBody>
@@ -12128,7 +12127,7 @@
                 <a:ea typeface="Songti SC"/>
                 <a:cs typeface="Songti SC"/>
               </a:rPr>
-              <a:t>演示数据：7 个学科库 / 24 份资料 / 46 个可检索片段，全部带出处</a:t>
+              <a:t>演示数据：7 个学科库 / 24 份资料 / 46 个可检索片段，全部带出处。</a:t>
             </a:r>
           </a:p>
         </p:txBody>

</xml_diff>